<commit_message>
Fill the submission fields and fix two unreadable labels
Slides 1 and 2 carried the template's own section names, "Title Page" and
"Idea Title", which say nothing about the work; they now name what the slide
is actually about.

Submission fields are filled in: problem statement 1, Clean & Green Technology,
student ID 23BAI10006. They no longer need the amber placeholder treatment, so
that line reverts to primary ink.

Two labels were effectively invisible:

  * "neutral" on the PMV distribution sat at y=0.05, directly on top of the
    baseline curve and the shaded comfort band - moved clear of the data and
    repainted in primary ink;
  * the per-zone bar values, which are the point of that chart, were drawn in
    secondary slate and read as dim beside the bars - now bold primary ink.

Co-Authored-By: Claude Opus 5 <noreply@anthropic.com>
</commit_message>
<xml_diff>
--- a/deck/Echo-Loop_Idea_Deck.pptx
+++ b/deck/Echo-Loop_Idea_Deck.pptx
@@ -4833,7 +4833,7 @@
                 </a:solidFill>
                 <a:latin typeface="Segoe UI"/>
               </a:rPr>
-              <a:t>TITLE PAGE</a:t>
+              <a:t>AUTONOMOUS BUILDING ENERGY MANAGEMENT</a:t>
             </a:r>
           </a:p>
         </p:txBody>
@@ -5280,11 +5280,11 @@
             <a:r>
               <a:rPr sz="1150" b="1">
                 <a:solidFill>
-                  <a:srgbClr val="F59E0B"/>
+                  <a:srgbClr val="F1F5F9"/>
                 </a:solidFill>
                 <a:latin typeface="Segoe UI"/>
               </a:rPr>
-              <a:t>Problem Statement ID  &lt;&lt;FILL IN&gt;&gt;      ·      Theme  &lt;&lt;FILL IN&gt;&gt;</a:t>
+              <a:t>Problem Statement ID  1      ·      Theme  Clean &amp; Green Technology</a:t>
             </a:r>
           </a:p>
           <a:p>
@@ -5301,7 +5301,7 @@
                 </a:solidFill>
                 <a:latin typeface="Segoe UI"/>
               </a:rPr>
-              <a:t>PS Category  Software      ·      Student  Ayush Yadav      ·      Student ID  &lt;&lt;FILL IN&gt;&gt;</a:t>
+              <a:t>PS Category  Software      ·      Student  Ayush Yadav      ·      Student ID  23BAI10006</a:t>
             </a:r>
           </a:p>
         </p:txBody>
@@ -6551,7 +6551,7 @@
                 </a:solidFill>
                 <a:latin typeface="Segoe UI"/>
               </a:rPr>
-              <a:t>IDEA TITLE</a:t>
+              <a:t>PROPOSED SOLUTION &amp; INNOVATION</a:t>
             </a:r>
           </a:p>
         </p:txBody>

</xml_diff>